<commit_message>
Architecture deck rebuilt with the shipped provider; previews and PDF
Co-Authored-By: Claude Fable 5.1 <noreply@anthropic.com>
</commit_message>
<xml_diff>
--- a/docs/deck/Guardian-Architecture.pptx
+++ b/docs/deck/Guardian-Architecture.pptx
@@ -42,7 +42,7 @@
     </p:embeddedFont>
     <p:embeddedFont>
       <p:font typeface="Lora" pitchFamily="2" charset="0"/>
-      <p:italic r:id="rId28"/>
+      <p:regular r:id="rId28"/>
     </p:embeddedFont>
     <p:embeddedFont>
       <p:font typeface="Roboto Slab" pitchFamily="2" charset="0"/>
@@ -188,7 +188,7 @@
     </p:spTree>
     <p:extLst>
       <p:ext uri="{BB962C8B-B14F-4D97-AF65-F5344CB8AC3E}">
-        <p14:creationId xmlns:p14="http://schemas.microsoft.com/office/powerpoint/2010/main" val="2217305004"/>
+        <p14:creationId xmlns:p14="http://schemas.microsoft.com/office/powerpoint/2010/main" val="739916476"/>
       </p:ext>
     </p:extLst>
   </p:cSld>
@@ -1937,7 +1937,7 @@
           <a:p>
             <a:fld id="{5BCAD085-E8A6-8845-BD4E-CB4CCA059FC4}" type="datetimeFigureOut">
               <a:rPr lang="en-US" smtClean="0"/>
-              <a:t>9/13/2026</a:t>
+              <a:t>9/14/2026</a:t>
             </a:fld>
             <a:endParaRPr lang="en-US"/>
           </a:p>
@@ -2105,7 +2105,7 @@
           <a:p>
             <a:fld id="{5BCAD085-E8A6-8845-BD4E-CB4CCA059FC4}" type="datetimeFigureOut">
               <a:rPr lang="en-US" smtClean="0"/>
-              <a:t>9/13/2026</a:t>
+              <a:t>9/14/2026</a:t>
             </a:fld>
             <a:endParaRPr lang="en-US"/>
           </a:p>
@@ -2283,7 +2283,7 @@
           <a:p>
             <a:fld id="{5BCAD085-E8A6-8845-BD4E-CB4CCA059FC4}" type="datetimeFigureOut">
               <a:rPr lang="en-US" smtClean="0"/>
-              <a:t>9/13/2026</a:t>
+              <a:t>9/14/2026</a:t>
             </a:fld>
             <a:endParaRPr lang="en-US"/>
           </a:p>
@@ -2451,7 +2451,7 @@
           <a:p>
             <a:fld id="{5BCAD085-E8A6-8845-BD4E-CB4CCA059FC4}" type="datetimeFigureOut">
               <a:rPr lang="en-US" smtClean="0"/>
-              <a:t>9/13/2026</a:t>
+              <a:t>9/14/2026</a:t>
             </a:fld>
             <a:endParaRPr lang="en-US"/>
           </a:p>
@@ -2696,7 +2696,7 @@
           <a:p>
             <a:fld id="{5BCAD085-E8A6-8845-BD4E-CB4CCA059FC4}" type="datetimeFigureOut">
               <a:rPr lang="en-US" smtClean="0"/>
-              <a:t>9/13/2026</a:t>
+              <a:t>9/14/2026</a:t>
             </a:fld>
             <a:endParaRPr lang="en-US"/>
           </a:p>
@@ -2981,7 +2981,7 @@
           <a:p>
             <a:fld id="{5BCAD085-E8A6-8845-BD4E-CB4CCA059FC4}" type="datetimeFigureOut">
               <a:rPr lang="en-US" smtClean="0"/>
-              <a:t>9/13/2026</a:t>
+              <a:t>9/14/2026</a:t>
             </a:fld>
             <a:endParaRPr lang="en-US"/>
           </a:p>
@@ -3400,7 +3400,7 @@
           <a:p>
             <a:fld id="{5BCAD085-E8A6-8845-BD4E-CB4CCA059FC4}" type="datetimeFigureOut">
               <a:rPr lang="en-US" smtClean="0"/>
-              <a:t>9/13/2026</a:t>
+              <a:t>9/14/2026</a:t>
             </a:fld>
             <a:endParaRPr lang="en-US"/>
           </a:p>
@@ -3517,7 +3517,7 @@
           <a:p>
             <a:fld id="{5BCAD085-E8A6-8845-BD4E-CB4CCA059FC4}" type="datetimeFigureOut">
               <a:rPr lang="en-US" smtClean="0"/>
-              <a:t>9/13/2026</a:t>
+              <a:t>9/14/2026</a:t>
             </a:fld>
             <a:endParaRPr lang="en-US"/>
           </a:p>
@@ -3612,7 +3612,7 @@
           <a:p>
             <a:fld id="{5BCAD085-E8A6-8845-BD4E-CB4CCA059FC4}" type="datetimeFigureOut">
               <a:rPr lang="en-US" smtClean="0"/>
-              <a:t>9/13/2026</a:t>
+              <a:t>9/14/2026</a:t>
             </a:fld>
             <a:endParaRPr lang="en-US"/>
           </a:p>
@@ -3887,7 +3887,7 @@
           <a:p>
             <a:fld id="{5BCAD085-E8A6-8845-BD4E-CB4CCA059FC4}" type="datetimeFigureOut">
               <a:rPr lang="en-US" smtClean="0"/>
-              <a:t>9/13/2026</a:t>
+              <a:t>9/14/2026</a:t>
             </a:fld>
             <a:endParaRPr lang="en-US"/>
           </a:p>
@@ -4139,7 +4139,7 @@
           <a:p>
             <a:fld id="{5BCAD085-E8A6-8845-BD4E-CB4CCA059FC4}" type="datetimeFigureOut">
               <a:rPr lang="en-US" smtClean="0"/>
-              <a:t>9/13/2026</a:t>
+              <a:t>9/14/2026</a:t>
             </a:fld>
             <a:endParaRPr lang="en-US"/>
           </a:p>
@@ -4350,7 +4350,7 @@
           <a:p>
             <a:fld id="{5BCAD085-E8A6-8845-BD4E-CB4CCA059FC4}" type="datetimeFigureOut">
               <a:rPr lang="en-US" smtClean="0"/>
-              <a:t>9/13/2026</a:t>
+              <a:t>9/14/2026</a:t>
             </a:fld>
             <a:endParaRPr lang="en-US"/>
           </a:p>
@@ -4865,7 +4865,7 @@
                 </a:solidFill>
                 <a:latin typeface="Lora"/>
               </a:rPr>
-              <a:t>The architecture: gren graphs on the Strands Agents SDK, Claude on Amazon Bedrock, one human gate, one household.</a:t>
+              <a:t>The architecture: gren graphs on the Strands Agents SDK, Claude through the Strands model provider (the Anthropic API today, Amazon Bedrock when the account is authorized), one human gate, one household.</a:t>
             </a:r>
           </a:p>
         </p:txBody>
@@ -28564,7 +28564,7 @@
                           </a:solidFill>
                           <a:latin typeface="Lora"/>
                         </a:rPr>
-                        <a:t>Amazon Bedrock, Claude</a:t>
+                        <a:t>Claude (Anthropic API today; Amazon Bedrock pending)</a:t>
                       </a:r>
                     </a:p>
                   </a:txBody>

</xml_diff>

<commit_message>
Architecture deck: shorter title subtitle
Co-Authored-By: Claude Fable 5.1 <noreply@anthropic.com>
</commit_message>
<xml_diff>
--- a/docs/deck/Guardian-Architecture.pptx
+++ b/docs/deck/Guardian-Architecture.pptx
@@ -188,7 +188,7 @@
     </p:spTree>
     <p:extLst>
       <p:ext uri="{BB962C8B-B14F-4D97-AF65-F5344CB8AC3E}">
-        <p14:creationId xmlns:p14="http://schemas.microsoft.com/office/powerpoint/2010/main" val="739916476"/>
+        <p14:creationId xmlns:p14="http://schemas.microsoft.com/office/powerpoint/2010/main" val="81428959"/>
       </p:ext>
     </p:extLst>
   </p:cSld>
@@ -4865,7 +4865,7 @@
                 </a:solidFill>
                 <a:latin typeface="Lora"/>
               </a:rPr>
-              <a:t>The architecture: gren graphs on the Strands Agents SDK, Claude through the Strands model provider (the Anthropic API today, Amazon Bedrock when the account is authorized), one human gate, one household.</a:t>
+              <a:t>The architecture: gren graphs on the Strands Agents SDK, Claude through the Strands model provider, one human gate, one household.</a:t>
             </a:r>
           </a:p>
         </p:txBody>

</xml_diff>